<commit_message>
Update editable text-first deck to current artifact content
The companion fallback deck (real text boxes, no captures) was stale
since July 18. Synced: title tagline, n8n card copy, checked Salesforce
step, diagnostic bubble + "Un seul probleme" verdict, VTC case wording
and steps, new Virtual Brain figures and cartography extract, and the
simplified three-cards slide.

Co-Authored-By: Claude Fable 5 <noreply@anthropic.com>
Claude-Session: https://claude.ai/code/session_01LhBsEGCwVttHSPT2zP54Mu
</commit_message>
<xml_diff>
--- a/LIA-concretement-Capital-Croissance.pptx
+++ b/LIA-concretement-Capital-Croissance.pptx
@@ -2065,7 +2065,7 @@
                 <a:ea typeface="Arial" pitchFamily="34" charset="-122"/>
                 <a:cs typeface="Arial" pitchFamily="34" charset="-120"/>
               </a:rPr>
-              <a:t>Ce que nous avons construit en deux mois, et ce que vous pouvez installer en sortant d’ici.</a:t>
+              <a:t>Ce que nous avons construit en deux mois, et ce que vous pourrez utiliser avant la fin du café.</a:t>
             </a:r>
             <a:endParaRPr lang="en-US" sz="1600" dirty="0"/>
           </a:p>
@@ -2366,7 +2366,7 @@
                 <a:ea typeface="Arial" pitchFamily="34" charset="-122"/>
                 <a:cs typeface="Arial" pitchFamily="34" charset="-120"/>
               </a:rPr>
-              <a:t>Un cas venu de l’équipe IR : des agents qui vont chercher, systématiquement, la même information dans chacune de nos participations, données sensibles comprises. Ici, la cartographie bancaire : deux régions (Bretagne + Pays de la Loire), une banque (Caisse d’Épargne), l’analyse tombe.</a:t>
+              <a:t>Un cas venu de l’équipe IR : des agents qui vont chercher, systématiquement, la même information dans chacune de nos participations, données sensibles comprises. Ici, la cartographie bancaire : deux régions, une banque, l’analyse tombe.</a:t>
             </a:r>
             <a:endParaRPr lang="en-US" sz="1500" dirty="0"/>
           </a:p>
@@ -2411,7 +2411,7 @@
                 <a:ea typeface="Arial" pitchFamily="34" charset="-122"/>
                 <a:cs typeface="Arial" pitchFamily="34" charset="-120"/>
               </a:rPr>
-              <a:t>104</a:t>
+              <a:t>34 / 44</a:t>
             </a:r>
             <a:pPr indent="0" marL="0">
               <a:lnSpc>
@@ -2431,7 +2431,7 @@
                 <a:ea typeface="Arial" pitchFamily="34" charset="-122"/>
                 <a:cs typeface="Arial" pitchFamily="34" charset="-120"/>
               </a:rPr>
-              <a:t>   relations bancaires rattachées au groupe BPCE</a:t>
+              <a:t>   participations en relation bancaire avec le groupe BPCE</a:t>
             </a:r>
             <a:endParaRPr lang="en-US" sz="1400" dirty="0"/>
           </a:p>
@@ -2454,7 +2454,7 @@
                 <a:ea typeface="Arial" pitchFamily="34" charset="-122"/>
                 <a:cs typeface="Arial" pitchFamily="34" charset="-120"/>
               </a:rPr>
-              <a:t>22,2 M€</a:t>
+              <a:t>62,8 M€</a:t>
             </a:r>
             <a:pPr indent="0" marL="0">
               <a:lnSpc>
@@ -2474,7 +2474,7 @@
                 <a:ea typeface="Arial" pitchFamily="34" charset="-122"/>
                 <a:cs typeface="Arial" pitchFamily="34" charset="-120"/>
               </a:rPr>
-              <a:t>   de prêt effectif, Tier 1 Caisse d’Épargne</a:t>
+              <a:t>   engagés par BPCE dans les opérations CC, cumul d’origine</a:t>
             </a:r>
             <a:endParaRPr lang="en-US" sz="1400" dirty="0"/>
           </a:p>
@@ -2497,7 +2497,7 @@
                 <a:ea typeface="Arial" pitchFamily="34" charset="-122"/>
                 <a:cs typeface="Arial" pitchFamily="34" charset="-120"/>
               </a:rPr>
-              <a:t>545</a:t>
+              <a:t>41</a:t>
             </a:r>
             <a:pPr indent="0" marL="0">
               <a:lnSpc>
@@ -2517,7 +2517,7 @@
                 <a:ea typeface="Arial" pitchFamily="34" charset="-122"/>
                 <a:cs typeface="Arial" pitchFamily="34" charset="-120"/>
               </a:rPr>
-              <a:t>   lignes de financement cartographiées</a:t>
+              <a:t>   lignes de financement BPCE tracées</a:t>
             </a:r>
             <a:endParaRPr lang="en-US" sz="1400" dirty="0"/>
           </a:p>
@@ -2576,7 +2576,7 @@
                 <a:ea typeface="Arial" pitchFamily="34" charset="-122"/>
                 <a:cs typeface="Arial" pitchFamily="34" charset="-120"/>
               </a:rPr>
-              <a:t>Caisse d’Épargne BPL 22,2 M€ · Banque Populaire Grand Ouest 14,8 M€ · Crédit Agricole 11,3 M€ · Autres (12 établissements) 31,5 M€</a:t>
+              <a:t>e-Testing · Caisse d’Épargne BPL 1,4 M€ · GERESO · BP Grand Ouest, senior 1,6 M€ · Oceanet · BPA, pool de 6 banques 5,8 M€ · ABE Courtage · CA, Arkéa, CMB hors BPCE</a:t>
             </a:r>
             <a:endParaRPr lang="en-US" sz="1300" dirty="0"/>
           </a:p>
@@ -2715,7 +2715,7 @@
           <a:p>
             <a:pPr indent="0" marL="0">
               <a:lnSpc>
-                <a:spcPts val="2600"/>
+                <a:spcPts val="3000"/>
               </a:lnSpc>
               <a:spcAft>
                 <a:spcPts val="1400"/>
@@ -2723,7 +2723,7 @@
               <a:buNone/>
             </a:pPr>
             <a:r>
-              <a:rPr lang="en-US" sz="1700" b="1" dirty="0">
+              <a:rPr lang="en-US" sz="2000" b="1" dirty="0">
                 <a:solidFill>
                   <a:srgbClr val="0488C1"/>
                 </a:solidFill>
@@ -2735,7 +2735,7 @@
             </a:r>
             <a:pPr indent="0" marL="0">
               <a:lnSpc>
-                <a:spcPts val="2600"/>
+                <a:spcPts val="3000"/>
               </a:lnSpc>
               <a:spcAft>
                 <a:spcPts val="1400"/>
@@ -2743,7 +2743,7 @@
               <a:buNone/>
             </a:pPr>
             <a:r>
-              <a:rPr lang="en-US" sz="1700" b="1" dirty="0">
+              <a:rPr lang="en-US" sz="2000" b="1" dirty="0">
                 <a:solidFill>
                   <a:srgbClr val="414142"/>
                 </a:solidFill>
@@ -2751,11 +2751,14 @@
                 <a:ea typeface="Arial" pitchFamily="34" charset="-122"/>
                 <a:cs typeface="Arial" pitchFamily="34" charset="-120"/>
               </a:rPr>
-              <a:t>Installez CR Express.  </a:t>
-            </a:r>
-            <a:pPr indent="0" marL="0">
-              <a:lnSpc>
-                <a:spcPts val="2600"/>
+              <a:t>Installez CR Express</a:t>
+            </a:r>
+            <a:endParaRPr lang="en-US" sz="2000" dirty="0"/>
+          </a:p>
+          <a:p>
+            <a:pPr indent="0" marL="0">
+              <a:lnSpc>
+                <a:spcPts val="3000"/>
               </a:lnSpc>
               <a:spcAft>
                 <a:spcPts val="1400"/>
@@ -2763,22 +2766,19 @@
               <a:buNone/>
             </a:pPr>
             <a:r>
-              <a:rPr lang="en-US" sz="1700" dirty="0">
-                <a:solidFill>
-                  <a:srgbClr val="6B6D72"/>
-                </a:solidFill>
-                <a:latin typeface="Arial" pitchFamily="34" charset="0"/>
-                <a:ea typeface="Arial" pitchFamily="34" charset="-122"/>
-                <a:cs typeface="Arial" pitchFamily="34" charset="-120"/>
-              </a:rPr>
-              <a:t>Dictez votre compte-rendu, validez quatre cartes : tout est rangé dans Salesforce.</a:t>
-            </a:r>
-            <a:endParaRPr lang="en-US" sz="1700" dirty="0"/>
-          </a:p>
-          <a:p>
-            <a:pPr indent="0" marL="0">
-              <a:lnSpc>
-                <a:spcPts val="2600"/>
+              <a:rPr lang="en-US" sz="2000" b="1" dirty="0">
+                <a:solidFill>
+                  <a:srgbClr val="0488C1"/>
+                </a:solidFill>
+                <a:latin typeface="Arial" pitchFamily="34" charset="0"/>
+                <a:ea typeface="Arial" pitchFamily="34" charset="-122"/>
+                <a:cs typeface="Arial" pitchFamily="34" charset="-120"/>
+              </a:rPr>
+              <a:t>02  </a:t>
+            </a:r>
+            <a:pPr indent="0" marL="0">
+              <a:lnSpc>
+                <a:spcPts val="3000"/>
               </a:lnSpc>
               <a:spcAft>
                 <a:spcPts val="1400"/>
@@ -2786,19 +2786,22 @@
               <a:buNone/>
             </a:pPr>
             <a:r>
-              <a:rPr lang="en-US" sz="1700" b="1" dirty="0">
-                <a:solidFill>
-                  <a:srgbClr val="0488C1"/>
-                </a:solidFill>
-                <a:latin typeface="Arial" pitchFamily="34" charset="0"/>
-                <a:ea typeface="Arial" pitchFamily="34" charset="-122"/>
-                <a:cs typeface="Arial" pitchFamily="34" charset="-120"/>
-              </a:rPr>
-              <a:t>02  </a:t>
-            </a:r>
-            <a:pPr indent="0" marL="0">
-              <a:lnSpc>
-                <a:spcPts val="2600"/>
+              <a:rPr lang="en-US" sz="2000" b="1" dirty="0">
+                <a:solidFill>
+                  <a:srgbClr val="414142"/>
+                </a:solidFill>
+                <a:latin typeface="Arial" pitchFamily="34" charset="0"/>
+                <a:ea typeface="Arial" pitchFamily="34" charset="-122"/>
+                <a:cs typeface="Arial" pitchFamily="34" charset="-120"/>
+              </a:rPr>
+              <a:t>Demandez un Brief Express</a:t>
+            </a:r>
+            <a:endParaRPr lang="en-US" sz="2000" dirty="0"/>
+          </a:p>
+          <a:p>
+            <a:pPr indent="0" marL="0">
+              <a:lnSpc>
+                <a:spcPts val="3000"/>
               </a:lnSpc>
               <a:spcAft>
                 <a:spcPts val="1400"/>
@@ -2806,19 +2809,19 @@
               <a:buNone/>
             </a:pPr>
             <a:r>
-              <a:rPr lang="en-US" sz="1700" b="1" dirty="0">
-                <a:solidFill>
-                  <a:srgbClr val="414142"/>
-                </a:solidFill>
-                <a:latin typeface="Arial" pitchFamily="34" charset="0"/>
-                <a:ea typeface="Arial" pitchFamily="34" charset="-122"/>
-                <a:cs typeface="Arial" pitchFamily="34" charset="-120"/>
-              </a:rPr>
-              <a:t>Demandez un Brief Express.  </a:t>
-            </a:r>
-            <a:pPr indent="0" marL="0">
-              <a:lnSpc>
-                <a:spcPts val="2600"/>
+              <a:rPr lang="en-US" sz="2000" b="1" dirty="0">
+                <a:solidFill>
+                  <a:srgbClr val="0488C1"/>
+                </a:solidFill>
+                <a:latin typeface="Arial" pitchFamily="34" charset="0"/>
+                <a:ea typeface="Arial" pitchFamily="34" charset="-122"/>
+                <a:cs typeface="Arial" pitchFamily="34" charset="-120"/>
+              </a:rPr>
+              <a:t>03  </a:t>
+            </a:r>
+            <a:pPr indent="0" marL="0">
+              <a:lnSpc>
+                <a:spcPts val="3000"/>
               </a:lnSpc>
               <a:spcAft>
                 <a:spcPts val="1400"/>
@@ -2826,50 +2829,7 @@
               <a:buNone/>
             </a:pPr>
             <a:r>
-              <a:rPr lang="en-US" sz="1700" dirty="0">
-                <a:solidFill>
-                  <a:srgbClr val="6B6D72"/>
-                </a:solidFill>
-                <a:latin typeface="Arial" pitchFamily="34" charset="0"/>
-                <a:ea typeface="Arial" pitchFamily="34" charset="-122"/>
-                <a:cs typeface="Arial" pitchFamily="34" charset="-120"/>
-              </a:rPr>
-              <a:t>Une phrase dans Teams, trente secondes : la fiche complète avant votre rendez-vous.</a:t>
-            </a:r>
-            <a:endParaRPr lang="en-US" sz="1700" dirty="0"/>
-          </a:p>
-          <a:p>
-            <a:pPr indent="0" marL="0">
-              <a:lnSpc>
-                <a:spcPts val="2600"/>
-              </a:lnSpc>
-              <a:spcAft>
-                <a:spcPts val="1400"/>
-              </a:spcAft>
-              <a:buNone/>
-            </a:pPr>
-            <a:r>
-              <a:rPr lang="en-US" sz="1700" b="1" dirty="0">
-                <a:solidFill>
-                  <a:srgbClr val="0488C1"/>
-                </a:solidFill>
-                <a:latin typeface="Arial" pitchFamily="34" charset="0"/>
-                <a:ea typeface="Arial" pitchFamily="34" charset="-122"/>
-                <a:cs typeface="Arial" pitchFamily="34" charset="-120"/>
-              </a:rPr>
-              <a:t>03  </a:t>
-            </a:r>
-            <a:pPr indent="0" marL="0">
-              <a:lnSpc>
-                <a:spcPts val="2600"/>
-              </a:lnSpc>
-              <a:spcAft>
-                <a:spcPts val="1400"/>
-              </a:spcAft>
-              <a:buNone/>
-            </a:pPr>
-            <a:r>
-              <a:rPr lang="en-US" sz="1700" b="1" dirty="0">
+              <a:rPr lang="en-US" sz="2000" b="1" dirty="0">
                 <a:solidFill>
                   <a:srgbClr val="414142"/>
                 </a:solidFill>
@@ -2877,29 +2837,9 @@
                 <a:ea typeface="Arial" pitchFamily="34" charset="-122"/>
                 <a:cs typeface="Arial" pitchFamily="34" charset="-120"/>
               </a:rPr>
-              <a:t>Parlez à Virtual Brain.  </a:t>
-            </a:r>
-            <a:pPr indent="0" marL="0">
-              <a:lnSpc>
-                <a:spcPts val="2600"/>
-              </a:lnSpc>
-              <a:spcAft>
-                <a:spcPts val="1400"/>
-              </a:spcAft>
-              <a:buNone/>
-            </a:pPr>
-            <a:r>
-              <a:rPr lang="en-US" sz="1700" dirty="0">
-                <a:solidFill>
-                  <a:srgbClr val="6B6D72"/>
-                </a:solidFill>
-                <a:latin typeface="Arial" pitchFamily="34" charset="0"/>
-                <a:ea typeface="Arial" pitchFamily="34" charset="-122"/>
-                <a:cs typeface="Arial" pitchFamily="34" charset="-120"/>
-              </a:rPr>
-              <a:t>Une question, toutes nos participations interrogées d’un coup.</a:t>
-            </a:r>
-            <a:endParaRPr lang="en-US" sz="1700" dirty="0"/>
+              <a:t>Parlez à Virtual Brain</a:t>
+            </a:r>
+            <a:endParaRPr lang="en-US" sz="2000" dirty="0"/>
           </a:p>
         </p:txBody>
       </p:sp>
@@ -3665,7 +3605,7 @@
                 <a:ea typeface="Arial" pitchFamily="34" charset="-122"/>
                 <a:cs typeface="Arial" pitchFamily="34" charset="-120"/>
               </a:rPr>
-              <a:t>C'est elle qui fait dialoguer le cerveau et la bibliothèque.</a:t>
+              <a:t>C'est elle qui les fait dialoguer.</a:t>
             </a:r>
             <a:endParaRPr lang="en-US" sz="1300" dirty="0"/>
           </a:p>
@@ -4049,7 +3989,7 @@
                 <a:ea typeface="Arial" pitchFamily="34" charset="-122"/>
                 <a:cs typeface="Arial" pitchFamily="34" charset="-120"/>
               </a:rPr>
-              <a:t>L'information est triée et rangée au bon endroit.</a:t>
+              <a:t>✓ L'information est triée et rangée au bon endroit.</a:t>
             </a:r>
             <a:endParaRPr lang="en-US" sz="1700" dirty="0"/>
           </a:p>
@@ -4151,7 +4091,7 @@
                 <a:ea typeface="Arial" pitchFamily="34" charset="-122"/>
                 <a:cs typeface="Arial" pitchFamily="34" charset="-120"/>
               </a:rPr>
-              <a:t>n8n, l'automate qui tire les fils.</a:t>
+              <a:t>n8n, l'automate qui tire les fils</a:t>
             </a:r>
             <a:endParaRPr lang="en-US" sz="1400" dirty="0"/>
           </a:p>
@@ -4349,7 +4289,7 @@
                 <a:ea typeface="Arial" pitchFamily="34" charset="-122"/>
                 <a:cs typeface="Arial" pitchFamily="34" charset="-120"/>
               </a:rPr>
-              <a:t>« Ce qui se dit en RDV reste chez ceux qui y étaient. »  </a:t>
+              <a:t>« Ce qui se dit en RDV, ça reste dans la tête de ceux qui y étaient. »  </a:t>
             </a:r>
             <a:pPr indent="0" marL="0">
               <a:lnSpc>
@@ -4494,7 +4434,7 @@
                 <a:ea typeface="Arial" pitchFamily="34" charset="-122"/>
                 <a:cs typeface="Arial" pitchFamily="34" charset="-120"/>
               </a:rPr>
-              <a:t>UN SEUL SUJET   </a:t>
+              <a:t>UN SEUL PROBLÈME   </a:t>
             </a:r>
             <a:pPr indent="0" marL="0">
               <a:buNone/>
@@ -4575,7 +4515,7 @@
                 <a:ea typeface="Arial" pitchFamily="34" charset="-122"/>
                 <a:cs typeface="Arial" pitchFamily="34" charset="-120"/>
               </a:rPr>
-              <a:t>Trois outils pour la mettre à portée de main.</a:t>
+              <a:t>Trois outils pour la rendre plus accessible.</a:t>
             </a:r>
             <a:endParaRPr lang="en-US" sz="2000" dirty="0"/>
           </a:p>
@@ -4795,7 +4735,7 @@
                 <a:ea typeface="Arial" pitchFamily="34" charset="-122"/>
                 <a:cs typeface="Arial" pitchFamily="34" charset="-120"/>
               </a:rPr>
-              <a:t>MIC</a:t>
+              <a:t>VTC</a:t>
             </a:r>
             <a:endParaRPr lang="en-US" sz="3400" dirty="0"/>
           </a:p>
@@ -4871,7 +4811,7 @@
                 <a:ea typeface="Arial" pitchFamily="34" charset="-122"/>
                 <a:cs typeface="Arial" pitchFamily="34" charset="-120"/>
               </a:rPr>
-              <a:t>, sur le bon compte, avec le bon contact — </a:t>
+              <a:t>, sur le bon compte, avec le bon contact, </a:t>
             </a:r>
             <a:pPr indent="0" marL="0">
               <a:lnSpc>
@@ -4888,7 +4828,7 @@
                 <a:ea typeface="Arial" pitchFamily="34" charset="-122"/>
                 <a:cs typeface="Arial" pitchFamily="34" charset="-120"/>
               </a:rPr>
-              <a:t>bref</a:t>
+              <a:t>bref.</a:t>
             </a:r>
             <a:pPr indent="0" marL="0">
               <a:lnSpc>
@@ -4905,7 +4845,7 @@
                 <a:ea typeface="Arial" pitchFamily="34" charset="-122"/>
                 <a:cs typeface="Arial" pitchFamily="34" charset="-120"/>
               </a:rPr>
-              <a:t>, au bon endroit.</a:t>
+              <a:t> au bon endroit.</a:t>
             </a:r>
             <a:endParaRPr lang="en-US" sz="1500" dirty="0"/>
           </a:p>
@@ -4970,7 +4910,7 @@
                 <a:ea typeface="Arial" pitchFamily="34" charset="-122"/>
                 <a:cs typeface="Arial" pitchFamily="34" charset="-120"/>
               </a:rPr>
-              <a:t>Vous dictez.</a:t>
+              <a:t>Vous dictez</a:t>
             </a:r>
             <a:endParaRPr lang="en-US" sz="1600" dirty="0"/>
           </a:p>
@@ -5013,7 +4953,7 @@
                 <a:ea typeface="Arial" pitchFamily="34" charset="-122"/>
                 <a:cs typeface="Arial" pitchFamily="34" charset="-120"/>
               </a:rPr>
-              <a:t>Quatre cartes arrivent dans votre chat : compte, fonds, compte rendu, écriture Salesforce.</a:t>
+              <a:t>Quatre cartes arrivent dans votre chat</a:t>
             </a:r>
             <a:endParaRPr lang="en-US" sz="1600" dirty="0"/>
           </a:p>
@@ -5056,7 +4996,7 @@
                 <a:ea typeface="Arial" pitchFamily="34" charset="-122"/>
                 <a:cs typeface="Arial" pitchFamily="34" charset="-120"/>
               </a:rPr>
-              <a:t>Vous validez.</a:t>
+              <a:t>Vous validez</a:t>
             </a:r>
             <a:endParaRPr lang="en-US" sz="1600" dirty="0"/>
           </a:p>
@@ -5538,7 +5478,7 @@
                 <a:ea typeface="Arial" pitchFamily="34" charset="-122"/>
                 <a:cs typeface="Arial" pitchFamily="34" charset="-120"/>
               </a:rPr>
-              <a:t>Vous écrivez comme vous parlez.</a:t>
+              <a:t>Vous écrivez comme vous parlez</a:t>
             </a:r>
             <a:endParaRPr lang="en-US" sz="1600" dirty="0"/>
           </a:p>
@@ -5581,7 +5521,7 @@
                 <a:ea typeface="Arial" pitchFamily="34" charset="-122"/>
                 <a:cs typeface="Arial" pitchFamily="34" charset="-120"/>
               </a:rPr>
-              <a:t>Il lit notre Salesforce.</a:t>
+              <a:t>Il lit notre Salesforce</a:t>
             </a:r>
             <a:endParaRPr lang="en-US" sz="1600" dirty="0"/>
           </a:p>
@@ -5624,7 +5564,7 @@
                 <a:ea typeface="Arial" pitchFamily="34" charset="-122"/>
                 <a:cs typeface="Arial" pitchFamily="34" charset="-120"/>
               </a:rPr>
-              <a:t>Puis il enrichit : CFnews, presse, registres.</a:t>
+              <a:t>Puis il enrichit : CFnews, presse, registres</a:t>
             </a:r>
             <a:endParaRPr lang="en-US" sz="1600" dirty="0"/>
           </a:p>
@@ -5985,7 +5925,7 @@
                 <a:ea typeface="Arial" pitchFamily="34" charset="-122"/>
                 <a:cs typeface="Arial" pitchFamily="34" charset="-120"/>
               </a:rPr>
-              <a:t>Dernier contact : le 7 juillet 2026 (dîner à Nantes)</a:t>
+              <a:t>Dernier contact : Le 7 juillet 2026 (dîner à Nantes)</a:t>
             </a:r>
             <a:endParaRPr lang="en-US" sz="1100" dirty="0"/>
           </a:p>

</xml_diff>